<commit_message>
F3 L28 and L30: categories (causes, features, effects, solutions) become sub-headings with listed points
Co-Authored-By: Claude Opus 5.5 <noreply@anthropic.com>
Claude-Session: https://claude.ai/code/session_0115LFSb2ktGLWPeVksFkSer
</commit_message>
<xml_diff>
--- a/lecons/F3/32_FORM4_LESSON28_Depositional_Features_Wind.pptx
+++ b/lecons/F3/32_FORM4_LESSON28_Depositional_Features_Wind.pptx
@@ -2750,7 +2750,7 @@
           <a:p>
             <a:r>
               <a:rPr lang="en-US" dirty="0"/>
-              <a:t>Let us copy Depositional Features of Wind Action. Wind deposition takes place and forms features as follows. On this slide we have Causes of deposition. Write each point on a new line, with the key term first, and explain it in your own words when we revise. When you finish, we go to the next slide.</a:t>
+              <a:t>Let us copy Causes of Deposition. The wind deposits its load for the following reasons. On this slide we have Fall in wind speed and Obstacles. Write each point on a new line, with the key term first, and explain it in your own words when we revise. When you finish, we go to the next slide.</a:t>
             </a:r>
             <a:endParaRPr lang="en-US" dirty="0"/>
           </a:p>
@@ -2838,7 +2838,7 @@
           <a:p>
             <a:r>
               <a:rPr lang="en-US" dirty="0"/>
-              <a:t>We continue with Depositional Features of Wind Action. On this slide we have Sand sheets and ripples. Write each point on a new line, with the key term first, and explain it in your own words when we revise.</a:t>
+              <a:t>We continue with Causes of Deposition. On this slide we have Wet sand. Write each point on a new line, with the key term first, and explain it in your own words when we revise.</a:t>
             </a:r>
             <a:endParaRPr lang="en-US" dirty="0"/>
           </a:p>
@@ -2926,7 +2926,7 @@
           <a:p>
             <a:r>
               <a:rPr lang="en-US" dirty="0"/>
-              <a:t>Copy the point on Sand dunes on the left, then draw the diagram on the right: how a dune moves. Give it a title and label it clearly.</a:t>
+              <a:t>Let us copy Features of Deposition. Wind deposition forms the following features. Copy the point on Sand dunes on the left, then draw the diagram on the right: how a dune moves. Give it a title and label it clearly.</a:t>
             </a:r>
             <a:endParaRPr lang="en-US" dirty="0"/>
           </a:p>
@@ -3014,7 +3014,7 @@
           <a:p>
             <a:r>
               <a:rPr lang="en-US" dirty="0"/>
-              <a:t>We continue with Depositional Features of Wind Action. On this slide we have Loess. Write each point on a new line, with the key term first, and explain it in your own words when we revise.</a:t>
+              <a:t>We continue with Features of Deposition. On this slide we have Sand sheets, Ripples and Loess. Write each point on a new line, with the key term first, and explain it in your own words when we revise.</a:t>
             </a:r>
             <a:endParaRPr lang="en-US" dirty="0"/>
           </a:p>
@@ -12675,7 +12675,7 @@
         <p:spPr>
           <a:xfrm>
             <a:off x="0" y="658368"/>
-            <a:ext cx="3840480" cy="5833872"/>
+            <a:ext cx="1463040" cy="5833872"/>
           </a:xfrm>
           <a:prstGeom prst="rect">
             <a:avLst/>
@@ -12690,8 +12690,8 @@
         </p:nvSpPr>
         <p:spPr>
           <a:xfrm>
-            <a:off x="4069080" y="1005840"/>
-            <a:ext cx="7802575" cy="731520"/>
+            <a:off x="1691640" y="1005840"/>
+            <a:ext cx="10180015" cy="731520"/>
           </a:xfrm>
           <a:prstGeom prst="rect">
             <a:avLst/>
@@ -12731,8 +12731,47 @@
         </p:nvSpPr>
         <p:spPr>
           <a:xfrm>
-            <a:off x="4069080" y="1783080"/>
-            <a:ext cx="7802575" cy="4663440"/>
+            <a:off x="1691640" y="1737360"/>
+            <a:ext cx="10180015" cy="457200"/>
+          </a:xfrm>
+          <a:prstGeom prst="rect">
+            <a:avLst/>
+          </a:prstGeom>
+          <a:noFill/>
+          <a:ln/>
+        </p:spPr>
+        <p:txBody>
+          <a:bodyPr wrap="square" lIns="0" tIns="0" rIns="0" bIns="0" rtlCol="0" anchor="ctr"/>
+          <a:lstStyle/>
+          <a:p>
+            <a:pPr algn="l" indent="0" marL="0">
+              <a:buNone/>
+            </a:pPr>
+            <a:r>
+              <a:rPr lang="en-US" sz="3200" b="1" dirty="0">
+                <a:solidFill>
+                  <a:srgbClr val="990011"/>
+                </a:solidFill>
+                <a:latin typeface="Times New Roman" pitchFamily="34" charset="0"/>
+                <a:ea typeface="Times New Roman" pitchFamily="34" charset="-122"/>
+                <a:cs typeface="Times New Roman" pitchFamily="34" charset="-120"/>
+              </a:rPr>
+              <a:t>A) Causes of Deposition</a:t>
+            </a:r>
+            <a:endParaRPr lang="en-US" sz="3200" dirty="0"/>
+          </a:p>
+        </p:txBody>
+      </p:sp>
+      <p:sp>
+        <p:nvSpPr>
+          <p:cNvPr id="6" name="Text 3"/>
+          <p:cNvSpPr/>
+          <p:nvPr/>
+        </p:nvSpPr>
+        <p:spPr>
+          <a:xfrm>
+            <a:off x="1691640" y="2240280"/>
+            <a:ext cx="10180015" cy="4206240"/>
           </a:xfrm>
           <a:prstGeom prst="rect">
             <a:avLst/>
@@ -12759,7 +12798,7 @@
                 <a:ea typeface="Times New Roman" pitchFamily="34" charset="-122"/>
                 <a:cs typeface="Times New Roman" pitchFamily="34" charset="-120"/>
               </a:rPr>
-              <a:t>Wind deposition takes place and forms features as follows:</a:t>
+              <a:t>The wind deposits its load for the following reasons:</a:t>
             </a:r>
             <a:endParaRPr lang="en-US" sz="4000" dirty="0"/>
           </a:p>
@@ -12779,7 +12818,7 @@
                 <a:ea typeface="Times New Roman" pitchFamily="34" charset="-122"/>
                 <a:cs typeface="Times New Roman" pitchFamily="34" charset="-120"/>
               </a:rPr>
-              <a:t>Causes of deposition: </a:t>
+              <a:t>Fall in wind speed: </a:t>
             </a:r>
             <a:pPr algn="l" indent="0" marL="0">
               <a:spcAft>
@@ -12796,7 +12835,44 @@
                 <a:ea typeface="Times New Roman" pitchFamily="34" charset="-122"/>
                 <a:cs typeface="Times New Roman" pitchFamily="34" charset="-120"/>
               </a:rPr>
-              <a:t>The wind drops sand when it slows down, meets an obstacle such as a rock or a bush, or when the sand becomes wet.</a:t>
+              <a:t>The wind slows down and can no longer carry the sand.</a:t>
+            </a:r>
+            <a:endParaRPr lang="en-US" sz="4000" dirty="0"/>
+          </a:p>
+          <a:p>
+            <a:pPr algn="l" indent="0" marL="0">
+              <a:spcAft>
+                <a:spcPts val="800"/>
+              </a:spcAft>
+              <a:buNone/>
+            </a:pPr>
+            <a:r>
+              <a:rPr lang="en-US" sz="4000" b="1" dirty="0">
+                <a:solidFill>
+                  <a:srgbClr val="111111"/>
+                </a:solidFill>
+                <a:latin typeface="Times New Roman" pitchFamily="34" charset="0"/>
+                <a:ea typeface="Times New Roman" pitchFamily="34" charset="-122"/>
+                <a:cs typeface="Times New Roman" pitchFamily="34" charset="-120"/>
+              </a:rPr>
+              <a:t>Obstacles: </a:t>
+            </a:r>
+            <a:pPr algn="l" indent="0" marL="0">
+              <a:spcAft>
+                <a:spcPts val="800"/>
+              </a:spcAft>
+              <a:buNone/>
+            </a:pPr>
+            <a:r>
+              <a:rPr lang="en-US" sz="4000" dirty="0">
+                <a:solidFill>
+                  <a:srgbClr val="111111"/>
+                </a:solidFill>
+                <a:latin typeface="Times New Roman" pitchFamily="34" charset="0"/>
+                <a:ea typeface="Times New Roman" pitchFamily="34" charset="-122"/>
+                <a:cs typeface="Times New Roman" pitchFamily="34" charset="-120"/>
+              </a:rPr>
+              <a:t>A rock, a bush or a wall stops the wind, and the sand piles up behind it.</a:t>
             </a:r>
             <a:endParaRPr lang="en-US" sz="4000" dirty="0"/>
           </a:p>
@@ -12973,7 +13049,7 @@
                 <a:ea typeface="Times New Roman" pitchFamily="34" charset="-122"/>
                 <a:cs typeface="Times New Roman" pitchFamily="34" charset="-120"/>
               </a:rPr>
-              <a:t>1. Depositional Features of Wind Action (continued)</a:t>
+              <a:t>1. Depositional Features of Wind Action</a:t>
             </a:r>
             <a:endParaRPr lang="en-US" sz="3600" dirty="0"/>
           </a:p>
@@ -12987,8 +13063,47 @@
         </p:nvSpPr>
         <p:spPr>
           <a:xfrm>
-            <a:off x="5349240" y="1783080"/>
-            <a:ext cx="6522415" cy="4663440"/>
+            <a:off x="5349240" y="1737360"/>
+            <a:ext cx="6522415" cy="457200"/>
+          </a:xfrm>
+          <a:prstGeom prst="rect">
+            <a:avLst/>
+          </a:prstGeom>
+          <a:noFill/>
+          <a:ln/>
+        </p:spPr>
+        <p:txBody>
+          <a:bodyPr wrap="square" lIns="0" tIns="0" rIns="0" bIns="0" rtlCol="0" anchor="ctr"/>
+          <a:lstStyle/>
+          <a:p>
+            <a:pPr algn="l" indent="0" marL="0">
+              <a:buNone/>
+            </a:pPr>
+            <a:r>
+              <a:rPr lang="en-US" sz="2900" b="1" dirty="0">
+                <a:solidFill>
+                  <a:srgbClr val="990011"/>
+                </a:solidFill>
+                <a:latin typeface="Times New Roman" pitchFamily="34" charset="0"/>
+                <a:ea typeface="Times New Roman" pitchFamily="34" charset="-122"/>
+                <a:cs typeface="Times New Roman" pitchFamily="34" charset="-120"/>
+              </a:rPr>
+              <a:t>A) Causes of Deposition (continued)</a:t>
+            </a:r>
+            <a:endParaRPr lang="en-US" sz="2900" dirty="0"/>
+          </a:p>
+        </p:txBody>
+      </p:sp>
+      <p:sp>
+        <p:nvSpPr>
+          <p:cNvPr id="6" name="Text 3"/>
+          <p:cNvSpPr/>
+          <p:nvPr/>
+        </p:nvSpPr>
+        <p:spPr>
+          <a:xfrm>
+            <a:off x="5349240" y="2240280"/>
+            <a:ext cx="6522415" cy="4206240"/>
           </a:xfrm>
           <a:prstGeom prst="rect">
             <a:avLst/>
@@ -13015,7 +13130,7 @@
                 <a:ea typeface="Times New Roman" pitchFamily="34" charset="-122"/>
                 <a:cs typeface="Times New Roman" pitchFamily="34" charset="-120"/>
               </a:rPr>
-              <a:t>Sand sheets and ripples: </a:t>
+              <a:t>Wet sand: </a:t>
             </a:r>
             <a:pPr algn="l" indent="0" marL="0">
               <a:spcAft>
@@ -13032,7 +13147,7 @@
                 <a:ea typeface="Times New Roman" pitchFamily="34" charset="-122"/>
                 <a:cs typeface="Times New Roman" pitchFamily="34" charset="-120"/>
               </a:rPr>
-              <a:t>Wide, flat spreads of sand are marked with small waves called ripples.</a:t>
+              <a:t>Damp sand sticks together and the wind cannot lift it.</a:t>
             </a:r>
             <a:endParaRPr lang="en-US" sz="4000" dirty="0"/>
           </a:p>
@@ -13199,8 +13314,49 @@
         </p:nvSpPr>
         <p:spPr>
           <a:xfrm>
-            <a:off x="365760" y="1783080"/>
-            <a:ext cx="4846320" cy="4617720"/>
+            <a:off x="365760" y="1737360"/>
+            <a:ext cx="5120640" cy="457200"/>
+          </a:xfrm>
+          <a:prstGeom prst="rect">
+            <a:avLst/>
+          </a:prstGeom>
+          <a:noFill/>
+          <a:ln/>
+        </p:spPr>
+        <p:txBody>
+          <a:bodyPr wrap="square" lIns="0" tIns="0" rIns="0" bIns="0" rtlCol="0" anchor="ctr">
+            <a:normAutofit/>
+          </a:bodyPr>
+          <a:lstStyle/>
+          <a:p>
+            <a:pPr algn="l" indent="0" marL="0">
+              <a:buNone/>
+            </a:pPr>
+            <a:r>
+              <a:rPr lang="en-US" sz="3000" b="1" dirty="0">
+                <a:solidFill>
+                  <a:srgbClr val="990011"/>
+                </a:solidFill>
+                <a:latin typeface="Times New Roman" pitchFamily="34" charset="0"/>
+                <a:ea typeface="Times New Roman" pitchFamily="34" charset="-122"/>
+                <a:cs typeface="Times New Roman" pitchFamily="34" charset="-120"/>
+              </a:rPr>
+              <a:t>B) Features of Deposition</a:t>
+            </a:r>
+            <a:endParaRPr lang="en-US" sz="3000" dirty="0"/>
+          </a:p>
+        </p:txBody>
+      </p:sp>
+      <p:sp>
+        <p:nvSpPr>
+          <p:cNvPr id="5" name="Text 3"/>
+          <p:cNvSpPr/>
+          <p:nvPr/>
+        </p:nvSpPr>
+        <p:spPr>
+          <a:xfrm>
+            <a:off x="365760" y="2240280"/>
+            <a:ext cx="4846320" cy="4160520"/>
           </a:xfrm>
           <a:prstGeom prst="rect">
             <a:avLst/>
@@ -13219,7 +13375,7 @@
               <a:buNone/>
             </a:pPr>
             <a:r>
-              <a:rPr lang="en-US" sz="3600" b="1" dirty="0">
+              <a:rPr lang="en-US" sz="3600" i="1" dirty="0">
                 <a:solidFill>
                   <a:srgbClr val="111111"/>
                 </a:solidFill>
@@ -13227,8 +13383,11 @@
                 <a:ea typeface="Times New Roman" pitchFamily="34" charset="-122"/>
                 <a:cs typeface="Times New Roman" pitchFamily="34" charset="-120"/>
               </a:rPr>
-              <a:t>Sand dunes: </a:t>
-            </a:r>
+              <a:t>Wind deposition forms the following features:</a:t>
+            </a:r>
+            <a:endParaRPr lang="en-US" sz="3600" dirty="0"/>
+          </a:p>
+          <a:p>
             <a:pPr algn="l" indent="0" marL="0">
               <a:spcAft>
                 <a:spcPts val="800"/>
@@ -13236,7 +13395,7 @@
               <a:buNone/>
             </a:pPr>
             <a:r>
-              <a:rPr lang="en-US" sz="3600" dirty="0">
+              <a:rPr lang="en-US" sz="3600" b="1" dirty="0">
                 <a:solidFill>
                   <a:srgbClr val="111111"/>
                 </a:solidFill>
@@ -13244,7 +13403,24 @@
                 <a:ea typeface="Times New Roman" pitchFamily="34" charset="-122"/>
                 <a:cs typeface="Times New Roman" pitchFamily="34" charset="-120"/>
               </a:rPr>
-              <a:t>Hills of sand with a gentle windward slope and a steep slip face that slowly move in the direction of the wind.</a:t>
+              <a:t>Sand dunes: </a:t>
+            </a:r>
+            <a:pPr algn="l" indent="0" marL="0">
+              <a:spcAft>
+                <a:spcPts val="800"/>
+              </a:spcAft>
+              <a:buNone/>
+            </a:pPr>
+            <a:r>
+              <a:rPr lang="en-US" sz="3600" dirty="0">
+                <a:solidFill>
+                  <a:srgbClr val="111111"/>
+                </a:solidFill>
+                <a:latin typeface="Times New Roman" pitchFamily="34" charset="0"/>
+                <a:ea typeface="Times New Roman" pitchFamily="34" charset="-122"/>
+                <a:cs typeface="Times New Roman" pitchFamily="34" charset="-120"/>
+              </a:rPr>
+              <a:t>They are hills of sand with a gentle windward slope and a steep slip face.</a:t>
             </a:r>
             <a:endParaRPr lang="en-US" sz="3600" dirty="0"/>
           </a:p>
@@ -13252,7 +13428,7 @@
       </p:sp>
       <p:pic>
         <p:nvPicPr>
-          <p:cNvPr id="5" name="Image 0" descr="/home/claude/f4/img/v2/dune_move_last.png">    </p:cNvPr>
+          <p:cNvPr id="6" name="Image 0" descr="/home/claude/f4/img/v2/dune_move_last.png">    </p:cNvPr>
           <p:cNvPicPr>
             <a:picLocks noChangeAspect="1"/>
           </p:cNvPicPr>
@@ -13276,7 +13452,7 @@
       </p:pic>
       <p:sp>
         <p:nvSpPr>
-          <p:cNvPr id="6" name="Text 3"/>
+          <p:cNvPr id="7" name="Text 4"/>
           <p:cNvSpPr/>
           <p:nvPr/>
         </p:nvSpPr>
@@ -13442,7 +13618,7 @@
         <p:spPr>
           <a:xfrm>
             <a:off x="0" y="658368"/>
-            <a:ext cx="5120640" cy="5833872"/>
+            <a:ext cx="1463040" cy="5833872"/>
           </a:xfrm>
           <a:prstGeom prst="rect">
             <a:avLst/>
@@ -13457,8 +13633,8 @@
         </p:nvSpPr>
         <p:spPr>
           <a:xfrm>
-            <a:off x="5349240" y="1005840"/>
-            <a:ext cx="6522415" cy="731520"/>
+            <a:off x="1691640" y="1005840"/>
+            <a:ext cx="10180015" cy="731520"/>
           </a:xfrm>
           <a:prstGeom prst="rect">
             <a:avLst/>
@@ -13498,8 +13674,8 @@
         </p:nvSpPr>
         <p:spPr>
           <a:xfrm>
-            <a:off x="5349240" y="1783080"/>
-            <a:ext cx="6522415" cy="4663440"/>
+            <a:off x="1691640" y="1737360"/>
+            <a:ext cx="10180015" cy="457200"/>
           </a:xfrm>
           <a:prstGeom prst="rect">
             <a:avLst/>
@@ -13508,8 +13684,121 @@
           <a:ln/>
         </p:spPr>
         <p:txBody>
+          <a:bodyPr wrap="square" lIns="0" tIns="0" rIns="0" bIns="0" rtlCol="0" anchor="ctr"/>
+          <a:lstStyle/>
+          <a:p>
+            <a:pPr algn="l" indent="0" marL="0">
+              <a:buNone/>
+            </a:pPr>
+            <a:r>
+              <a:rPr lang="en-US" sz="3200" b="1" dirty="0">
+                <a:solidFill>
+                  <a:srgbClr val="990011"/>
+                </a:solidFill>
+                <a:latin typeface="Times New Roman" pitchFamily="34" charset="0"/>
+                <a:ea typeface="Times New Roman" pitchFamily="34" charset="-122"/>
+                <a:cs typeface="Times New Roman" pitchFamily="34" charset="-120"/>
+              </a:rPr>
+              <a:t>B) Features of Deposition</a:t>
+            </a:r>
+            <a:endParaRPr lang="en-US" sz="3200" dirty="0"/>
+          </a:p>
+        </p:txBody>
+      </p:sp>
+      <p:sp>
+        <p:nvSpPr>
+          <p:cNvPr id="6" name="Text 3"/>
+          <p:cNvSpPr/>
+          <p:nvPr/>
+        </p:nvSpPr>
+        <p:spPr>
+          <a:xfrm>
+            <a:off x="1691640" y="2240280"/>
+            <a:ext cx="10180015" cy="4206240"/>
+          </a:xfrm>
+          <a:prstGeom prst="rect">
+            <a:avLst/>
+          </a:prstGeom>
+          <a:noFill/>
+          <a:ln/>
+        </p:spPr>
+        <p:txBody>
           <a:bodyPr wrap="square" lIns="0" tIns="0" rIns="0" bIns="0" rtlCol="0" anchor="t"/>
           <a:lstStyle/>
+          <a:p>
+            <a:pPr algn="l" indent="0" marL="0">
+              <a:spcAft>
+                <a:spcPts val="800"/>
+              </a:spcAft>
+              <a:buNone/>
+            </a:pPr>
+            <a:r>
+              <a:rPr lang="en-US" sz="4000" b="1" dirty="0">
+                <a:solidFill>
+                  <a:srgbClr val="111111"/>
+                </a:solidFill>
+                <a:latin typeface="Times New Roman" pitchFamily="34" charset="0"/>
+                <a:ea typeface="Times New Roman" pitchFamily="34" charset="-122"/>
+                <a:cs typeface="Times New Roman" pitchFamily="34" charset="-120"/>
+              </a:rPr>
+              <a:t>Sand sheets: </a:t>
+            </a:r>
+            <a:pPr algn="l" indent="0" marL="0">
+              <a:spcAft>
+                <a:spcPts val="800"/>
+              </a:spcAft>
+              <a:buNone/>
+            </a:pPr>
+            <a:r>
+              <a:rPr lang="en-US" sz="4000" dirty="0">
+                <a:solidFill>
+                  <a:srgbClr val="111111"/>
+                </a:solidFill>
+                <a:latin typeface="Times New Roman" pitchFamily="34" charset="0"/>
+                <a:ea typeface="Times New Roman" pitchFamily="34" charset="-122"/>
+                <a:cs typeface="Times New Roman" pitchFamily="34" charset="-120"/>
+              </a:rPr>
+              <a:t>They are wide, flat spreads of sand.</a:t>
+            </a:r>
+            <a:endParaRPr lang="en-US" sz="4000" dirty="0"/>
+          </a:p>
+          <a:p>
+            <a:pPr algn="l" indent="0" marL="0">
+              <a:spcAft>
+                <a:spcPts val="800"/>
+              </a:spcAft>
+              <a:buNone/>
+            </a:pPr>
+            <a:r>
+              <a:rPr lang="en-US" sz="4000" b="1" dirty="0">
+                <a:solidFill>
+                  <a:srgbClr val="111111"/>
+                </a:solidFill>
+                <a:latin typeface="Times New Roman" pitchFamily="34" charset="0"/>
+                <a:ea typeface="Times New Roman" pitchFamily="34" charset="-122"/>
+                <a:cs typeface="Times New Roman" pitchFamily="34" charset="-120"/>
+              </a:rPr>
+              <a:t>Ripples: </a:t>
+            </a:r>
+            <a:pPr algn="l" indent="0" marL="0">
+              <a:spcAft>
+                <a:spcPts val="800"/>
+              </a:spcAft>
+              <a:buNone/>
+            </a:pPr>
+            <a:r>
+              <a:rPr lang="en-US" sz="4000" dirty="0">
+                <a:solidFill>
+                  <a:srgbClr val="111111"/>
+                </a:solidFill>
+                <a:latin typeface="Times New Roman" pitchFamily="34" charset="0"/>
+                <a:ea typeface="Times New Roman" pitchFamily="34" charset="-122"/>
+                <a:cs typeface="Times New Roman" pitchFamily="34" charset="-120"/>
+              </a:rPr>
+              <a:t>They are small waves of sand on the surface of sand sheets and dunes.</a:t>
+            </a:r>
+            <a:endParaRPr lang="en-US" sz="4000" dirty="0"/>
+          </a:p>
           <a:p>
             <a:pPr algn="l" indent="0" marL="0">
               <a:spcAft>
@@ -18396,7 +18685,7 @@
                           <a:ea typeface="Calibri" pitchFamily="34" charset="-122"/>
                           <a:cs typeface="Calibri" pitchFamily="34" charset="-120"/>
                         </a:rPr>
-                        <a:t>DEFINITIONS; Depositional Features of Wind Action; Dunes.</a:t>
+                        <a:t>DEFINITIONS; Causes of Deposition; Features of Deposition; Dunes.</a:t>
                       </a:r>
                       <a:endParaRPr lang="en-US" sz="1600" dirty="0">
                         <a:latin typeface="Calibri" charset="0"/>

</xml_diff>